<commit_message>
Add LC116 tax Scenario B (Supermetal regime + ISS split), CPTM note, and update local-taxes simulation deck
</commit_message>
<xml_diff>
--- a/MRS_Pathfinder_Simulation_Local_Taxes_Bilingual.pptx
+++ b/MRS_Pathfinder_Simulation_Local_Taxes_Bilingual.pptx
@@ -173,9 +173,9 @@
           </c:dLbls>
           <c:cat>
             <c:strRef>
-              <c:f>Sheet1!$A$2:$A$5</c:f>
+              <c:f>Sheet1!$A$2:$A$6</c:f>
               <c:strCache>
-                <c:ptCount val="4"/>
+                <c:ptCount val="5"/>
                 <c:pt idx="0">
                   <c:v>1  Base
 (2 battery sets,
@@ -192,16 +192,21 @@
                 <c:pt idx="3">
                   <c:v>4  No II +
 one battery set</c:v>
+                </c:pt>
+                <c:pt idx="4">
+                  <c:v>US reference
+(US$900k US price
+landed in Brazil)</c:v>
                 </c:pt>
               </c:strCache>
             </c:strRef>
           </c:cat>
           <c:val>
             <c:numRef>
-              <c:f>Sheet1!$B$2:$B$5</c:f>
+              <c:f>Sheet1!$B$2:$B$6</c:f>
               <c:numCache>
                 <c:formatCode>General</c:formatCode>
-                <c:ptCount val="4"/>
+                <c:ptCount val="5"/>
                 <c:pt idx="0">
                   <c:v>945</c:v>
                 </c:pt>
@@ -263,9 +268,9 @@
           </c:dLbls>
           <c:cat>
             <c:strRef>
-              <c:f>Sheet1!$A$2:$A$5</c:f>
+              <c:f>Sheet1!$A$2:$A$6</c:f>
               <c:strCache>
-                <c:ptCount val="4"/>
+                <c:ptCount val="5"/>
                 <c:pt idx="0">
                   <c:v>1  Base
 (2 battery sets,
@@ -282,16 +287,21 @@
                 <c:pt idx="3">
                   <c:v>4  No II +
 one battery set</c:v>
+                </c:pt>
+                <c:pt idx="4">
+                  <c:v>US reference
+(US$900k US price
+landed in Brazil)</c:v>
                 </c:pt>
               </c:strCache>
             </c:strRef>
           </c:cat>
           <c:val>
             <c:numRef>
-              <c:f>Sheet1!$C$2:$C$5</c:f>
+              <c:f>Sheet1!$C$2:$C$6</c:f>
               <c:numCache>
                 <c:formatCode>General</c:formatCode>
-                <c:ptCount val="4"/>
+                <c:ptCount val="5"/>
                 <c:pt idx="0">
                   <c:v>461</c:v>
                 </c:pt>
@@ -303,6 +313,302 @@
                 </c:pt>
                 <c:pt idx="3">
                   <c:v>396</c:v>
+                </c:pt>
+              </c:numCache>
+            </c:numRef>
+          </c:val>
+        </c:ser>
+        <c:ser>
+          <c:idx val="2"/>
+          <c:order val="2"/>
+          <c:tx>
+            <c:strRef>
+              <c:f>Sheet1!$D$1</c:f>
+              <c:strCache>
+                <c:ptCount val="1"/>
+                <c:pt idx="0">
+                  <c:v>US reference: US price (product)</c:v>
+                </c:pt>
+              </c:strCache>
+            </c:strRef>
+          </c:tx>
+          <c:spPr>
+            <a:solidFill>
+              <a:srgbClr val="757588"/>
+            </a:solidFill>
+          </c:spPr>
+          <c:dLbls>
+            <c:numFmt formatCode="&quot;US$&quot;0&quot;k&quot;" sourceLinked="0"/>
+            <c:txPr>
+              <a:bodyPr/>
+              <a:lstStyle/>
+              <a:p>
+                <a:pPr>
+                  <a:defRPr sz="1200" b="1">
+                    <a:solidFill>
+                      <a:srgbClr val="FFFFFF"/>
+                    </a:solidFill>
+                  </a:defRPr>
+                </a:pPr>
+              </a:p>
+            </c:txPr>
+            <c:dLblPos val="ctr"/>
+            <c:showLegendKey val="0"/>
+            <c:showVal val="1"/>
+            <c:showCatName val="0"/>
+            <c:showSerName val="0"/>
+            <c:showPercent val="0"/>
+            <c:showBubbleSize val="0"/>
+            <c:showLeaderLines val="1"/>
+          </c:dLbls>
+          <c:cat>
+            <c:strRef>
+              <c:f>Sheet1!$A$2:$A$6</c:f>
+              <c:strCache>
+                <c:ptCount val="5"/>
+                <c:pt idx="0">
+                  <c:v>1  Base
+(2 battery sets,
+import duty in)</c:v>
+                </c:pt>
+                <c:pt idx="1">
+                  <c:v>2  No import
+duty (II = 0)</c:v>
+                </c:pt>
+                <c:pt idx="2">
+                  <c:v>3  One battery
+set (II in)</c:v>
+                </c:pt>
+                <c:pt idx="3">
+                  <c:v>4  No II +
+one battery set</c:v>
+                </c:pt>
+                <c:pt idx="4">
+                  <c:v>US reference
+(US$900k US price
+landed in Brazil)</c:v>
+                </c:pt>
+              </c:strCache>
+            </c:strRef>
+          </c:cat>
+          <c:val>
+            <c:numRef>
+              <c:f>Sheet1!$D$2:$D$6</c:f>
+              <c:numCache>
+                <c:formatCode>General</c:formatCode>
+                <c:ptCount val="5"/>
+                <c:pt idx="4">
+                  <c:v>899.9999999999999</c:v>
+                </c:pt>
+              </c:numCache>
+            </c:numRef>
+          </c:val>
+        </c:ser>
+        <c:ser>
+          <c:idx val="3"/>
+          <c:order val="3"/>
+          <c:tx>
+            <c:strRef>
+              <c:f>Sheet1!$E$1</c:f>
+              <c:strCache>
+                <c:ptCount val="1"/>
+                <c:pt idx="0">
+                  <c:v>US reference: freight + insurance</c:v>
+                </c:pt>
+              </c:strCache>
+            </c:strRef>
+          </c:tx>
+          <c:spPr>
+            <a:solidFill>
+              <a:srgbClr val="00847E"/>
+            </a:solidFill>
+          </c:spPr>
+          <c:cat>
+            <c:strRef>
+              <c:f>Sheet1!$A$2:$A$6</c:f>
+              <c:strCache>
+                <c:ptCount val="5"/>
+                <c:pt idx="0">
+                  <c:v>1  Base
+(2 battery sets,
+import duty in)</c:v>
+                </c:pt>
+                <c:pt idx="1">
+                  <c:v>2  No import
+duty (II = 0)</c:v>
+                </c:pt>
+                <c:pt idx="2">
+                  <c:v>3  One battery
+set (II in)</c:v>
+                </c:pt>
+                <c:pt idx="3">
+                  <c:v>4  No II +
+one battery set</c:v>
+                </c:pt>
+                <c:pt idx="4">
+                  <c:v>US reference
+(US$900k US price
+landed in Brazil)</c:v>
+                </c:pt>
+              </c:strCache>
+            </c:strRef>
+          </c:cat>
+          <c:val>
+            <c:numRef>
+              <c:f>Sheet1!$E$2:$E$6</c:f>
+              <c:numCache>
+                <c:formatCode>General</c:formatCode>
+                <c:ptCount val="5"/>
+                <c:pt idx="4">
+                  <c:v>80.49</c:v>
+                </c:pt>
+              </c:numCache>
+            </c:numRef>
+          </c:val>
+        </c:ser>
+        <c:ser>
+          <c:idx val="4"/>
+          <c:order val="4"/>
+          <c:tx>
+            <c:strRef>
+              <c:f>Sheet1!$F$1</c:f>
+              <c:strCache>
+                <c:ptCount val="1"/>
+                <c:pt idx="0">
+                  <c:v>US reference: customs / import expenses</c:v>
+                </c:pt>
+              </c:strCache>
+            </c:strRef>
+          </c:tx>
+          <c:spPr>
+            <a:solidFill>
+              <a:srgbClr val="FFAB18"/>
+            </a:solidFill>
+          </c:spPr>
+          <c:cat>
+            <c:strRef>
+              <c:f>Sheet1!$A$2:$A$6</c:f>
+              <c:strCache>
+                <c:ptCount val="5"/>
+                <c:pt idx="0">
+                  <c:v>1  Base
+(2 battery sets,
+import duty in)</c:v>
+                </c:pt>
+                <c:pt idx="1">
+                  <c:v>2  No import
+duty (II = 0)</c:v>
+                </c:pt>
+                <c:pt idx="2">
+                  <c:v>3  One battery
+set (II in)</c:v>
+                </c:pt>
+                <c:pt idx="3">
+                  <c:v>4  No II +
+one battery set</c:v>
+                </c:pt>
+                <c:pt idx="4">
+                  <c:v>US reference
+(US$900k US price
+landed in Brazil)</c:v>
+                </c:pt>
+              </c:strCache>
+            </c:strRef>
+          </c:cat>
+          <c:val>
+            <c:numRef>
+              <c:f>Sheet1!$F$2:$F$6</c:f>
+              <c:numCache>
+                <c:formatCode>General</c:formatCode>
+                <c:ptCount val="5"/>
+                <c:pt idx="4">
+                  <c:v>16.842856601941747</c:v>
+                </c:pt>
+              </c:numCache>
+            </c:numRef>
+          </c:val>
+        </c:ser>
+        <c:ser>
+          <c:idx val="5"/>
+          <c:order val="5"/>
+          <c:tx>
+            <c:strRef>
+              <c:f>Sheet1!$G$1</c:f>
+              <c:strCache>
+                <c:ptCount val="1"/>
+                <c:pt idx="0">
+                  <c:v>US reference: all import taxes</c:v>
+                </c:pt>
+              </c:strCache>
+            </c:strRef>
+          </c:tx>
+          <c:spPr>
+            <a:solidFill>
+              <a:srgbClr val="3685C0"/>
+            </a:solidFill>
+          </c:spPr>
+          <c:dLbls>
+            <c:numFmt formatCode="&quot;US$&quot;0&quot;k&quot;" sourceLinked="0"/>
+            <c:txPr>
+              <a:bodyPr/>
+              <a:lstStyle/>
+              <a:p>
+                <a:pPr>
+                  <a:defRPr sz="1200" b="1">
+                    <a:solidFill>
+                      <a:srgbClr val="FFFFFF"/>
+                    </a:solidFill>
+                  </a:defRPr>
+                </a:pPr>
+              </a:p>
+            </c:txPr>
+            <c:dLblPos val="ctr"/>
+            <c:showLegendKey val="0"/>
+            <c:showVal val="1"/>
+            <c:showCatName val="0"/>
+            <c:showSerName val="0"/>
+            <c:showPercent val="0"/>
+            <c:showBubbleSize val="0"/>
+            <c:showLeaderLines val="1"/>
+          </c:dLbls>
+          <c:cat>
+            <c:strRef>
+              <c:f>Sheet1!$A$2:$A$6</c:f>
+              <c:strCache>
+                <c:ptCount val="5"/>
+                <c:pt idx="0">
+                  <c:v>1  Base
+(2 battery sets,
+import duty in)</c:v>
+                </c:pt>
+                <c:pt idx="1">
+                  <c:v>2  No import
+duty (II = 0)</c:v>
+                </c:pt>
+                <c:pt idx="2">
+                  <c:v>3  One battery
+set (II in)</c:v>
+                </c:pt>
+                <c:pt idx="3">
+                  <c:v>4  No II +
+one battery set</c:v>
+                </c:pt>
+                <c:pt idx="4">
+                  <c:v>US reference
+(US$900k US price
+landed in Brazil)</c:v>
+                </c:pt>
+              </c:strCache>
+            </c:strRef>
+          </c:cat>
+          <c:val>
+            <c:numRef>
+              <c:f>Sheet1!$G$2:$G$6</c:f>
+              <c:numCache>
+                <c:formatCode>General</c:formatCode>
+                <c:ptCount val="5"/>
+                <c:pt idx="4">
+                  <c:v>715.6979140243899</c:v>
                 </c:pt>
               </c:numCache>
             </c:numRef>
@@ -335,7 +641,7 @@
           <a:lstStyle/>
           <a:p>
             <a:pPr>
-              <a:defRPr sz="1100"/>
+              <a:defRPr sz="1000"/>
             </a:pPr>
           </a:p>
         </c:txPr>
@@ -349,7 +655,7 @@
       <c:valAx>
         <c:axId val="-2113994440"/>
         <c:scaling>
-          <c:max val="1600.0"/>
+          <c:max val="1900.0"/>
           <c:min val="0.0"/>
         </c:scaling>
         <c:delete/>
@@ -363,13 +669,29 @@
     </c:plotArea>
     <c:legend>
       <c:legendPos val="b"/>
+      <c:legendEntry>
+        <c:idx val="2"/>
+        <c:delete val="1"/>
+      </c:legendEntry>
+      <c:legendEntry>
+        <c:idx val="3"/>
+        <c:delete val="1"/>
+      </c:legendEntry>
+      <c:legendEntry>
+        <c:idx val="4"/>
+        <c:delete val="1"/>
+      </c:legendEntry>
+      <c:legendEntry>
+        <c:idx val="5"/>
+        <c:delete val="1"/>
+      </c:legendEntry>
       <c:overlay val="0"/>
       <c:txPr>
         <a:bodyPr/>
         <a:lstStyle/>
         <a:p>
           <a:pPr>
-            <a:defRPr sz="1100"/>
+            <a:defRPr sz="1000"/>
           </a:pPr>
         </a:p>
       </c:txPr>
@@ -462,9 +784,9 @@
           </c:dLbls>
           <c:cat>
             <c:strRef>
-              <c:f>Sheet1!$A$2:$A$5</c:f>
+              <c:f>Sheet1!$A$2:$A$6</c:f>
               <c:strCache>
-                <c:ptCount val="4"/>
+                <c:ptCount val="5"/>
                 <c:pt idx="0">
                   <c:v>1  Base
 (2 jogos de baterias,
@@ -481,16 +803,21 @@
                 <c:pt idx="3">
                   <c:v>4  Sem II +
 um jogo de baterias</c:v>
+                </c:pt>
+                <c:pt idx="4">
+                  <c:v>Referência EUA
+(preço EUA US$900k
+posto no Brasil)</c:v>
                 </c:pt>
               </c:strCache>
             </c:strRef>
           </c:cat>
           <c:val>
             <c:numRef>
-              <c:f>Sheet1!$B$2:$B$5</c:f>
+              <c:f>Sheet1!$B$2:$B$6</c:f>
               <c:numCache>
                 <c:formatCode>General</c:formatCode>
-                <c:ptCount val="4"/>
+                <c:ptCount val="5"/>
                 <c:pt idx="0">
                   <c:v>945</c:v>
                 </c:pt>
@@ -552,9 +879,9 @@
           </c:dLbls>
           <c:cat>
             <c:strRef>
-              <c:f>Sheet1!$A$2:$A$5</c:f>
+              <c:f>Sheet1!$A$2:$A$6</c:f>
               <c:strCache>
-                <c:ptCount val="4"/>
+                <c:ptCount val="5"/>
                 <c:pt idx="0">
                   <c:v>1  Base
 (2 jogos de baterias,
@@ -571,16 +898,21 @@
                 <c:pt idx="3">
                   <c:v>4  Sem II +
 um jogo de baterias</c:v>
+                </c:pt>
+                <c:pt idx="4">
+                  <c:v>Referência EUA
+(preço EUA US$900k
+posto no Brasil)</c:v>
                 </c:pt>
               </c:strCache>
             </c:strRef>
           </c:cat>
           <c:val>
             <c:numRef>
-              <c:f>Sheet1!$C$2:$C$5</c:f>
+              <c:f>Sheet1!$C$2:$C$6</c:f>
               <c:numCache>
                 <c:formatCode>General</c:formatCode>
-                <c:ptCount val="4"/>
+                <c:ptCount val="5"/>
                 <c:pt idx="0">
                   <c:v>461</c:v>
                 </c:pt>
@@ -592,6 +924,302 @@
                 </c:pt>
                 <c:pt idx="3">
                   <c:v>396</c:v>
+                </c:pt>
+              </c:numCache>
+            </c:numRef>
+          </c:val>
+        </c:ser>
+        <c:ser>
+          <c:idx val="2"/>
+          <c:order val="2"/>
+          <c:tx>
+            <c:strRef>
+              <c:f>Sheet1!$D$1</c:f>
+              <c:strCache>
+                <c:ptCount val="1"/>
+                <c:pt idx="0">
+                  <c:v>Referência EUA: preço EUA (produto)</c:v>
+                </c:pt>
+              </c:strCache>
+            </c:strRef>
+          </c:tx>
+          <c:spPr>
+            <a:solidFill>
+              <a:srgbClr val="757588"/>
+            </a:solidFill>
+          </c:spPr>
+          <c:dLbls>
+            <c:numFmt formatCode="&quot;US$&quot;0&quot;k&quot;" sourceLinked="0"/>
+            <c:txPr>
+              <a:bodyPr/>
+              <a:lstStyle/>
+              <a:p>
+                <a:pPr>
+                  <a:defRPr sz="1200" b="1">
+                    <a:solidFill>
+                      <a:srgbClr val="FFFFFF"/>
+                    </a:solidFill>
+                  </a:defRPr>
+                </a:pPr>
+              </a:p>
+            </c:txPr>
+            <c:dLblPos val="ctr"/>
+            <c:showLegendKey val="0"/>
+            <c:showVal val="1"/>
+            <c:showCatName val="0"/>
+            <c:showSerName val="0"/>
+            <c:showPercent val="0"/>
+            <c:showBubbleSize val="0"/>
+            <c:showLeaderLines val="1"/>
+          </c:dLbls>
+          <c:cat>
+            <c:strRef>
+              <c:f>Sheet1!$A$2:$A$6</c:f>
+              <c:strCache>
+                <c:ptCount val="5"/>
+                <c:pt idx="0">
+                  <c:v>1  Base
+(2 jogos de baterias,
+II incluído)</c:v>
+                </c:pt>
+                <c:pt idx="1">
+                  <c:v>2  Sem imposto de
+importação (II = 0)</c:v>
+                </c:pt>
+                <c:pt idx="2">
+                  <c:v>3  Um jogo de
+baterias (II incluído)</c:v>
+                </c:pt>
+                <c:pt idx="3">
+                  <c:v>4  Sem II +
+um jogo de baterias</c:v>
+                </c:pt>
+                <c:pt idx="4">
+                  <c:v>Referência EUA
+(preço EUA US$900k
+posto no Brasil)</c:v>
+                </c:pt>
+              </c:strCache>
+            </c:strRef>
+          </c:cat>
+          <c:val>
+            <c:numRef>
+              <c:f>Sheet1!$D$2:$D$6</c:f>
+              <c:numCache>
+                <c:formatCode>General</c:formatCode>
+                <c:ptCount val="5"/>
+                <c:pt idx="4">
+                  <c:v>899.9999999999999</c:v>
+                </c:pt>
+              </c:numCache>
+            </c:numRef>
+          </c:val>
+        </c:ser>
+        <c:ser>
+          <c:idx val="3"/>
+          <c:order val="3"/>
+          <c:tx>
+            <c:strRef>
+              <c:f>Sheet1!$E$1</c:f>
+              <c:strCache>
+                <c:ptCount val="1"/>
+                <c:pt idx="0">
+                  <c:v>Referência EUA: frete + seguro</c:v>
+                </c:pt>
+              </c:strCache>
+            </c:strRef>
+          </c:tx>
+          <c:spPr>
+            <a:solidFill>
+              <a:srgbClr val="00847E"/>
+            </a:solidFill>
+          </c:spPr>
+          <c:cat>
+            <c:strRef>
+              <c:f>Sheet1!$A$2:$A$6</c:f>
+              <c:strCache>
+                <c:ptCount val="5"/>
+                <c:pt idx="0">
+                  <c:v>1  Base
+(2 jogos de baterias,
+II incluído)</c:v>
+                </c:pt>
+                <c:pt idx="1">
+                  <c:v>2  Sem imposto de
+importação (II = 0)</c:v>
+                </c:pt>
+                <c:pt idx="2">
+                  <c:v>3  Um jogo de
+baterias (II incluído)</c:v>
+                </c:pt>
+                <c:pt idx="3">
+                  <c:v>4  Sem II +
+um jogo de baterias</c:v>
+                </c:pt>
+                <c:pt idx="4">
+                  <c:v>Referência EUA
+(preço EUA US$900k
+posto no Brasil)</c:v>
+                </c:pt>
+              </c:strCache>
+            </c:strRef>
+          </c:cat>
+          <c:val>
+            <c:numRef>
+              <c:f>Sheet1!$E$2:$E$6</c:f>
+              <c:numCache>
+                <c:formatCode>General</c:formatCode>
+                <c:ptCount val="5"/>
+                <c:pt idx="4">
+                  <c:v>80.49</c:v>
+                </c:pt>
+              </c:numCache>
+            </c:numRef>
+          </c:val>
+        </c:ser>
+        <c:ser>
+          <c:idx val="4"/>
+          <c:order val="4"/>
+          <c:tx>
+            <c:strRef>
+              <c:f>Sheet1!$F$1</c:f>
+              <c:strCache>
+                <c:ptCount val="1"/>
+                <c:pt idx="0">
+                  <c:v>Referência EUA: despesas aduaneiras</c:v>
+                </c:pt>
+              </c:strCache>
+            </c:strRef>
+          </c:tx>
+          <c:spPr>
+            <a:solidFill>
+              <a:srgbClr val="FFAB18"/>
+            </a:solidFill>
+          </c:spPr>
+          <c:cat>
+            <c:strRef>
+              <c:f>Sheet1!$A$2:$A$6</c:f>
+              <c:strCache>
+                <c:ptCount val="5"/>
+                <c:pt idx="0">
+                  <c:v>1  Base
+(2 jogos de baterias,
+II incluído)</c:v>
+                </c:pt>
+                <c:pt idx="1">
+                  <c:v>2  Sem imposto de
+importação (II = 0)</c:v>
+                </c:pt>
+                <c:pt idx="2">
+                  <c:v>3  Um jogo de
+baterias (II incluído)</c:v>
+                </c:pt>
+                <c:pt idx="3">
+                  <c:v>4  Sem II +
+um jogo de baterias</c:v>
+                </c:pt>
+                <c:pt idx="4">
+                  <c:v>Referência EUA
+(preço EUA US$900k
+posto no Brasil)</c:v>
+                </c:pt>
+              </c:strCache>
+            </c:strRef>
+          </c:cat>
+          <c:val>
+            <c:numRef>
+              <c:f>Sheet1!$F$2:$F$6</c:f>
+              <c:numCache>
+                <c:formatCode>General</c:formatCode>
+                <c:ptCount val="5"/>
+                <c:pt idx="4">
+                  <c:v>16.842856601941747</c:v>
+                </c:pt>
+              </c:numCache>
+            </c:numRef>
+          </c:val>
+        </c:ser>
+        <c:ser>
+          <c:idx val="5"/>
+          <c:order val="5"/>
+          <c:tx>
+            <c:strRef>
+              <c:f>Sheet1!$G$1</c:f>
+              <c:strCache>
+                <c:ptCount val="1"/>
+                <c:pt idx="0">
+                  <c:v>Referência EUA: todos os impostos de importação</c:v>
+                </c:pt>
+              </c:strCache>
+            </c:strRef>
+          </c:tx>
+          <c:spPr>
+            <a:solidFill>
+              <a:srgbClr val="3685C0"/>
+            </a:solidFill>
+          </c:spPr>
+          <c:dLbls>
+            <c:numFmt formatCode="&quot;US$&quot;0&quot;k&quot;" sourceLinked="0"/>
+            <c:txPr>
+              <a:bodyPr/>
+              <a:lstStyle/>
+              <a:p>
+                <a:pPr>
+                  <a:defRPr sz="1200" b="1">
+                    <a:solidFill>
+                      <a:srgbClr val="FFFFFF"/>
+                    </a:solidFill>
+                  </a:defRPr>
+                </a:pPr>
+              </a:p>
+            </c:txPr>
+            <c:dLblPos val="ctr"/>
+            <c:showLegendKey val="0"/>
+            <c:showVal val="1"/>
+            <c:showCatName val="0"/>
+            <c:showSerName val="0"/>
+            <c:showPercent val="0"/>
+            <c:showBubbleSize val="0"/>
+            <c:showLeaderLines val="1"/>
+          </c:dLbls>
+          <c:cat>
+            <c:strRef>
+              <c:f>Sheet1!$A$2:$A$6</c:f>
+              <c:strCache>
+                <c:ptCount val="5"/>
+                <c:pt idx="0">
+                  <c:v>1  Base
+(2 jogos de baterias,
+II incluído)</c:v>
+                </c:pt>
+                <c:pt idx="1">
+                  <c:v>2  Sem imposto de
+importação (II = 0)</c:v>
+                </c:pt>
+                <c:pt idx="2">
+                  <c:v>3  Um jogo de
+baterias (II incluído)</c:v>
+                </c:pt>
+                <c:pt idx="3">
+                  <c:v>4  Sem II +
+um jogo de baterias</c:v>
+                </c:pt>
+                <c:pt idx="4">
+                  <c:v>Referência EUA
+(preço EUA US$900k
+posto no Brasil)</c:v>
+                </c:pt>
+              </c:strCache>
+            </c:strRef>
+          </c:cat>
+          <c:val>
+            <c:numRef>
+              <c:f>Sheet1!$G$2:$G$6</c:f>
+              <c:numCache>
+                <c:formatCode>General</c:formatCode>
+                <c:ptCount val="5"/>
+                <c:pt idx="4">
+                  <c:v>715.6979140243899</c:v>
                 </c:pt>
               </c:numCache>
             </c:numRef>
@@ -624,7 +1252,7 @@
           <a:lstStyle/>
           <a:p>
             <a:pPr>
-              <a:defRPr sz="1100"/>
+              <a:defRPr sz="1000"/>
             </a:pPr>
           </a:p>
         </c:txPr>
@@ -638,7 +1266,7 @@
       <c:valAx>
         <c:axId val="-2113994440"/>
         <c:scaling>
-          <c:max val="1600.0"/>
+          <c:max val="1900.0"/>
           <c:min val="0.0"/>
         </c:scaling>
         <c:delete/>
@@ -652,13 +1280,29 @@
     </c:plotArea>
     <c:legend>
       <c:legendPos val="b"/>
+      <c:legendEntry>
+        <c:idx val="2"/>
+        <c:delete val="1"/>
+      </c:legendEntry>
+      <c:legendEntry>
+        <c:idx val="3"/>
+        <c:delete val="1"/>
+      </c:legendEntry>
+      <c:legendEntry>
+        <c:idx val="4"/>
+        <c:delete val="1"/>
+      </c:legendEntry>
+      <c:legendEntry>
+        <c:idx val="5"/>
+        <c:delete val="1"/>
+      </c:legendEntry>
       <c:overlay val="0"/>
       <c:txPr>
         <a:bodyPr/>
         <a:lstStyle/>
         <a:p>
           <a:pPr>
-            <a:defRPr sz="1100"/>
+            <a:defRPr sz="1000"/>
           </a:pPr>
         </a:p>
       </c:txPr>
@@ -3788,8 +4432,8 @@
         </p:nvSpPr>
         <p:spPr>
           <a:xfrm>
-            <a:off x="560070" y="1344259"/>
-            <a:ext cx="1463040" cy="420624"/>
+            <a:off x="654893" y="1679204"/>
+            <a:ext cx="1005840" cy="420624"/>
           </a:xfrm>
           <a:prstGeom prst="rect">
             <a:avLst/>
@@ -3820,7 +4464,7 @@
           <a:p>
             <a:pPr algn="ctr"/>
             <a:r>
-              <a:rPr sz="1600" b="1">
+              <a:rPr sz="1400" b="1">
                 <a:solidFill>
                   <a:srgbClr val="2B2A2F"/>
                 </a:solidFill>
@@ -3839,8 +4483,8 @@
         </p:nvSpPr>
         <p:spPr>
           <a:xfrm>
-            <a:off x="1897837" y="1569064"/>
-            <a:ext cx="1463040" cy="420624"/>
+            <a:off x="1725107" y="1868513"/>
+            <a:ext cx="1005840" cy="420624"/>
           </a:xfrm>
           <a:prstGeom prst="rect">
             <a:avLst/>
@@ -3871,7 +4515,7 @@
           <a:p>
             <a:pPr algn="ctr"/>
             <a:r>
-              <a:rPr sz="1600" b="1">
+              <a:rPr sz="1400" b="1">
                 <a:solidFill>
                   <a:srgbClr val="2B2A2F"/>
                 </a:solidFill>
@@ -3890,8 +4534,8 @@
         </p:nvSpPr>
         <p:spPr>
           <a:xfrm>
-            <a:off x="3235604" y="1428750"/>
-            <a:ext cx="1463040" cy="420624"/>
+            <a:off x="2795320" y="1750354"/>
+            <a:ext cx="1005840" cy="420624"/>
           </a:xfrm>
           <a:prstGeom prst="rect">
             <a:avLst/>
@@ -3922,7 +4566,7 @@
           <a:p>
             <a:pPr algn="ctr"/>
             <a:r>
-              <a:rPr sz="1600" b="1">
+              <a:rPr sz="1400" b="1">
                 <a:solidFill>
                   <a:srgbClr val="2B2A2F"/>
                 </a:solidFill>
@@ -3941,8 +4585,8 @@
         </p:nvSpPr>
         <p:spPr>
           <a:xfrm>
-            <a:off x="4573371" y="1639976"/>
-            <a:ext cx="1463040" cy="420624"/>
+            <a:off x="3865534" y="1928228"/>
+            <a:ext cx="1005840" cy="420624"/>
           </a:xfrm>
           <a:prstGeom prst="rect">
             <a:avLst/>
@@ -3973,7 +4617,7 @@
           <a:p>
             <a:pPr algn="ctr"/>
             <a:r>
-              <a:rPr sz="1600" b="1">
+              <a:rPr sz="1400" b="1">
                 <a:solidFill>
                   <a:srgbClr val="2B2A2F"/>
                 </a:solidFill>
@@ -3984,42 +4628,57 @@
           </a:p>
         </p:txBody>
       </p:sp>
-      <p:cxnSp>
-        <p:nvCxnSpPr>
-          <p:cNvPr id="9" name="Connector 8"/>
-          <p:cNvCxnSpPr/>
+      <p:sp>
+        <p:nvSpPr>
+          <p:cNvPr id="9" name="Rectangle 8"/>
+          <p:cNvSpPr/>
           <p:nvPr/>
-        </p:nvCxnSpPr>
+        </p:nvSpPr>
         <p:spPr>
           <a:xfrm>
-            <a:off x="622706" y="2564891"/>
-            <a:ext cx="5488229" cy="0"/>
+            <a:off x="4935748" y="1289149"/>
+            <a:ext cx="1005840" cy="420624"/>
           </a:xfrm>
-          <a:prstGeom prst="line">
+          <a:prstGeom prst="rect">
             <a:avLst/>
           </a:prstGeom>
-          <a:ln w="22225">
-            <a:solidFill>
-              <a:srgbClr val="2B2A2F"/>
-            </a:solidFill>
-            <a:prstDash val="dash"/>
+          <a:noFill/>
+          <a:ln>
+            <a:noFill/>
           </a:ln>
+          <a:effectLst/>
         </p:spPr>
         <p:style>
-          <a:lnRef idx="2">
+          <a:lnRef idx="1">
             <a:schemeClr val="accent1"/>
           </a:lnRef>
-          <a:fillRef idx="0">
+          <a:fillRef idx="3">
             <a:schemeClr val="accent1"/>
           </a:fillRef>
-          <a:effectRef idx="1">
+          <a:effectRef idx="2">
             <a:schemeClr val="accent1"/>
           </a:effectRef>
           <a:fontRef idx="minor">
-            <a:schemeClr val="tx1"/>
+            <a:schemeClr val="lt1"/>
           </a:fontRef>
         </p:style>
-      </p:cxnSp>
+        <p:txBody>
+          <a:bodyPr rtlCol="0" anchor="b" wrap="square" lIns="0" tIns="0" rIns="0" bIns="18288"/>
+          <a:lstStyle/>
+          <a:p>
+            <a:pPr algn="ctr"/>
+            <a:r>
+              <a:rPr sz="1400" b="1">
+                <a:solidFill>
+                  <a:srgbClr val="2B2A2F"/>
+                </a:solidFill>
+                <a:latin typeface="Aptos Display"/>
+              </a:rPr>
+              <a:t>US$1,713k</a:t>
+            </a:r>
+          </a:p>
+        </p:txBody>
+      </p:sp>
       <p:sp>
         <p:nvSpPr>
           <p:cNvPr id="10" name="Rectangle 9"/>
@@ -4028,8 +4687,149 @@
         </p:nvSpPr>
         <p:spPr>
           <a:xfrm>
-            <a:off x="6138367" y="2199132"/>
-            <a:ext cx="1313992" cy="731520"/>
+            <a:off x="5783898" y="2708318"/>
+            <a:ext cx="265176" cy="18288"/>
+          </a:xfrm>
+          <a:prstGeom prst="rect">
+            <a:avLst/>
+          </a:prstGeom>
+          <a:solidFill>
+            <a:srgbClr val="00847E"/>
+          </a:solidFill>
+          <a:ln>
+            <a:noFill/>
+          </a:ln>
+          <a:effectLst/>
+        </p:spPr>
+        <p:style>
+          <a:lnRef idx="1">
+            <a:schemeClr val="accent1"/>
+          </a:lnRef>
+          <a:fillRef idx="3">
+            <a:schemeClr val="accent1"/>
+          </a:fillRef>
+          <a:effectRef idx="2">
+            <a:schemeClr val="accent1"/>
+          </a:effectRef>
+          <a:fontRef idx="minor">
+            <a:schemeClr val="lt1"/>
+          </a:fontRef>
+        </p:style>
+        <p:txBody>
+          <a:bodyPr rtlCol="0" anchor="ctr"/>
+          <a:lstStyle/>
+          <a:p>
+            <a:pPr algn="ctr"/>
+          </a:p>
+        </p:txBody>
+      </p:sp>
+      <p:sp>
+        <p:nvSpPr>
+          <p:cNvPr id="11" name="Rectangle 10"/>
+          <p:cNvSpPr/>
+          <p:nvPr/>
+        </p:nvSpPr>
+        <p:spPr>
+          <a:xfrm>
+            <a:off x="6049074" y="1188720"/>
+            <a:ext cx="1631885" cy="310896"/>
+          </a:xfrm>
+          <a:prstGeom prst="rect">
+            <a:avLst/>
+          </a:prstGeom>
+          <a:solidFill>
+            <a:srgbClr val="003158"/>
+          </a:solidFill>
+          <a:ln>
+            <a:noFill/>
+          </a:ln>
+          <a:effectLst/>
+        </p:spPr>
+        <p:style>
+          <a:lnRef idx="1">
+            <a:schemeClr val="accent1"/>
+          </a:lnRef>
+          <a:fillRef idx="3">
+            <a:schemeClr val="accent1"/>
+          </a:fillRef>
+          <a:effectRef idx="2">
+            <a:schemeClr val="accent1"/>
+          </a:effectRef>
+          <a:fontRef idx="minor">
+            <a:schemeClr val="lt1"/>
+          </a:fontRef>
+        </p:style>
+        <p:txBody>
+          <a:bodyPr rtlCol="0" anchor="ctr" wrap="square" tIns="27432" rIns="73152" bIns="27432"/>
+          <a:lstStyle/>
+          <a:p>
+            <a:pPr algn="l"/>
+            <a:r>
+              <a:rPr sz="1100" b="1">
+                <a:solidFill>
+                  <a:srgbClr val="FFFFFF"/>
+                </a:solidFill>
+                <a:latin typeface="Aptos"/>
+              </a:rPr>
+              <a:t>How the US$900k becomes US$1,713k</a:t>
+            </a:r>
+          </a:p>
+        </p:txBody>
+      </p:sp>
+      <p:sp>
+        <p:nvSpPr>
+          <p:cNvPr id="12" name="Rectangle 11"/>
+          <p:cNvSpPr/>
+          <p:nvPr/>
+        </p:nvSpPr>
+        <p:spPr>
+          <a:xfrm>
+            <a:off x="6049074" y="1517904"/>
+            <a:ext cx="82296" cy="384048"/>
+          </a:xfrm>
+          <a:prstGeom prst="rect">
+            <a:avLst/>
+          </a:prstGeom>
+          <a:solidFill>
+            <a:srgbClr val="757588"/>
+          </a:solidFill>
+          <a:ln>
+            <a:noFill/>
+          </a:ln>
+          <a:effectLst/>
+        </p:spPr>
+        <p:style>
+          <a:lnRef idx="1">
+            <a:schemeClr val="accent1"/>
+          </a:lnRef>
+          <a:fillRef idx="3">
+            <a:schemeClr val="accent1"/>
+          </a:fillRef>
+          <a:effectRef idx="2">
+            <a:schemeClr val="accent1"/>
+          </a:effectRef>
+          <a:fontRef idx="minor">
+            <a:schemeClr val="lt1"/>
+          </a:fontRef>
+        </p:style>
+        <p:txBody>
+          <a:bodyPr rtlCol="0" anchor="ctr"/>
+          <a:lstStyle/>
+          <a:p>
+            <a:pPr algn="ctr"/>
+          </a:p>
+        </p:txBody>
+      </p:sp>
+      <p:sp>
+        <p:nvSpPr>
+          <p:cNvPr id="13" name="Rectangle 12"/>
+          <p:cNvSpPr/>
+          <p:nvPr/>
+        </p:nvSpPr>
+        <p:spPr>
+          <a:xfrm>
+            <a:off x="6131370" y="1517904"/>
+            <a:ext cx="1549589" cy="384048"/>
           </a:xfrm>
           <a:prstGeom prst="rect">
             <a:avLst/>
@@ -4037,6 +4837,396 @@
           <a:solidFill>
             <a:srgbClr val="F8F8F8"/>
           </a:solidFill>
+          <a:ln>
+            <a:noFill/>
+          </a:ln>
+          <a:effectLst/>
+        </p:spPr>
+        <p:style>
+          <a:lnRef idx="1">
+            <a:schemeClr val="accent1"/>
+          </a:lnRef>
+          <a:fillRef idx="3">
+            <a:schemeClr val="accent1"/>
+          </a:fillRef>
+          <a:effectRef idx="2">
+            <a:schemeClr val="accent1"/>
+          </a:effectRef>
+          <a:fontRef idx="minor">
+            <a:schemeClr val="lt1"/>
+          </a:fontRef>
+        </p:style>
+        <p:txBody>
+          <a:bodyPr rtlCol="0" anchor="t" wrap="square" lIns="73152" tIns="27432" rIns="54864" bIns="18288"/>
+          <a:lstStyle/>
+          <a:p>
+            <a:pPr algn="l"/>
+            <a:r>
+              <a:rPr sz="1200" b="1">
+                <a:solidFill>
+                  <a:srgbClr val="2B2A2F"/>
+                </a:solidFill>
+                <a:latin typeface="Aptos Display"/>
+              </a:rPr>
+              <a:t>US$900k</a:t>
+            </a:r>
+          </a:p>
+          <a:p>
+            <a:pPr algn="l"/>
+            <a:r>
+              <a:rPr sz="800" b="0">
+                <a:solidFill>
+                  <a:srgbClr val="2B2A2F"/>
+                </a:solidFill>
+                <a:latin typeface="Aptos"/>
+              </a:rPr>
+              <a:t>US price (product, unchanged)</a:t>
+            </a:r>
+          </a:p>
+        </p:txBody>
+      </p:sp>
+      <p:sp>
+        <p:nvSpPr>
+          <p:cNvPr id="14" name="Rectangle 13"/>
+          <p:cNvSpPr/>
+          <p:nvPr/>
+        </p:nvSpPr>
+        <p:spPr>
+          <a:xfrm>
+            <a:off x="6049074" y="1920240"/>
+            <a:ext cx="82296" cy="384048"/>
+          </a:xfrm>
+          <a:prstGeom prst="rect">
+            <a:avLst/>
+          </a:prstGeom>
+          <a:solidFill>
+            <a:srgbClr val="00847E"/>
+          </a:solidFill>
+          <a:ln>
+            <a:noFill/>
+          </a:ln>
+          <a:effectLst/>
+        </p:spPr>
+        <p:style>
+          <a:lnRef idx="1">
+            <a:schemeClr val="accent1"/>
+          </a:lnRef>
+          <a:fillRef idx="3">
+            <a:schemeClr val="accent1"/>
+          </a:fillRef>
+          <a:effectRef idx="2">
+            <a:schemeClr val="accent1"/>
+          </a:effectRef>
+          <a:fontRef idx="minor">
+            <a:schemeClr val="lt1"/>
+          </a:fontRef>
+        </p:style>
+        <p:txBody>
+          <a:bodyPr rtlCol="0" anchor="ctr"/>
+          <a:lstStyle/>
+          <a:p>
+            <a:pPr algn="ctr"/>
+          </a:p>
+        </p:txBody>
+      </p:sp>
+      <p:sp>
+        <p:nvSpPr>
+          <p:cNvPr id="15" name="Rectangle 14"/>
+          <p:cNvSpPr/>
+          <p:nvPr/>
+        </p:nvSpPr>
+        <p:spPr>
+          <a:xfrm>
+            <a:off x="6131370" y="1920240"/>
+            <a:ext cx="1549589" cy="384048"/>
+          </a:xfrm>
+          <a:prstGeom prst="rect">
+            <a:avLst/>
+          </a:prstGeom>
+          <a:solidFill>
+            <a:srgbClr val="F8F8F8"/>
+          </a:solidFill>
+          <a:ln>
+            <a:noFill/>
+          </a:ln>
+          <a:effectLst/>
+        </p:spPr>
+        <p:style>
+          <a:lnRef idx="1">
+            <a:schemeClr val="accent1"/>
+          </a:lnRef>
+          <a:fillRef idx="3">
+            <a:schemeClr val="accent1"/>
+          </a:fillRef>
+          <a:effectRef idx="2">
+            <a:schemeClr val="accent1"/>
+          </a:effectRef>
+          <a:fontRef idx="minor">
+            <a:schemeClr val="lt1"/>
+          </a:fontRef>
+        </p:style>
+        <p:txBody>
+          <a:bodyPr rtlCol="0" anchor="t" wrap="square" lIns="73152" tIns="27432" rIns="54864" bIns="18288"/>
+          <a:lstStyle/>
+          <a:p>
+            <a:pPr algn="l"/>
+            <a:r>
+              <a:rPr sz="1200" b="1">
+                <a:solidFill>
+                  <a:srgbClr val="2B2A2F"/>
+                </a:solidFill>
+                <a:latin typeface="Aptos Display"/>
+              </a:rPr>
+              <a:t>US$80k</a:t>
+            </a:r>
+          </a:p>
+          <a:p>
+            <a:pPr algn="l"/>
+            <a:r>
+              <a:rPr sz="800" b="0">
+                <a:solidFill>
+                  <a:srgbClr val="2B2A2F"/>
+                </a:solidFill>
+                <a:latin typeface="Aptos"/>
+              </a:rPr>
+              <a:t>+ Freight + insurance</a:t>
+            </a:r>
+          </a:p>
+        </p:txBody>
+      </p:sp>
+      <p:sp>
+        <p:nvSpPr>
+          <p:cNvPr id="16" name="Rectangle 15"/>
+          <p:cNvSpPr/>
+          <p:nvPr/>
+        </p:nvSpPr>
+        <p:spPr>
+          <a:xfrm>
+            <a:off x="6049074" y="2322576"/>
+            <a:ext cx="82296" cy="420624"/>
+          </a:xfrm>
+          <a:prstGeom prst="rect">
+            <a:avLst/>
+          </a:prstGeom>
+          <a:solidFill>
+            <a:srgbClr val="FFAB18"/>
+          </a:solidFill>
+          <a:ln>
+            <a:noFill/>
+          </a:ln>
+          <a:effectLst/>
+        </p:spPr>
+        <p:style>
+          <a:lnRef idx="1">
+            <a:schemeClr val="accent1"/>
+          </a:lnRef>
+          <a:fillRef idx="3">
+            <a:schemeClr val="accent1"/>
+          </a:fillRef>
+          <a:effectRef idx="2">
+            <a:schemeClr val="accent1"/>
+          </a:effectRef>
+          <a:fontRef idx="minor">
+            <a:schemeClr val="lt1"/>
+          </a:fontRef>
+        </p:style>
+        <p:txBody>
+          <a:bodyPr rtlCol="0" anchor="ctr"/>
+          <a:lstStyle/>
+          <a:p>
+            <a:pPr algn="ctr"/>
+          </a:p>
+        </p:txBody>
+      </p:sp>
+      <p:sp>
+        <p:nvSpPr>
+          <p:cNvPr id="17" name="Rectangle 16"/>
+          <p:cNvSpPr/>
+          <p:nvPr/>
+        </p:nvSpPr>
+        <p:spPr>
+          <a:xfrm>
+            <a:off x="6131370" y="2322576"/>
+            <a:ext cx="1549589" cy="420624"/>
+          </a:xfrm>
+          <a:prstGeom prst="rect">
+            <a:avLst/>
+          </a:prstGeom>
+          <a:solidFill>
+            <a:srgbClr val="F8F8F8"/>
+          </a:solidFill>
+          <a:ln>
+            <a:noFill/>
+          </a:ln>
+          <a:effectLst/>
+        </p:spPr>
+        <p:style>
+          <a:lnRef idx="1">
+            <a:schemeClr val="accent1"/>
+          </a:lnRef>
+          <a:fillRef idx="3">
+            <a:schemeClr val="accent1"/>
+          </a:fillRef>
+          <a:effectRef idx="2">
+            <a:schemeClr val="accent1"/>
+          </a:effectRef>
+          <a:fontRef idx="minor">
+            <a:schemeClr val="lt1"/>
+          </a:fontRef>
+        </p:style>
+        <p:txBody>
+          <a:bodyPr rtlCol="0" anchor="t" wrap="square" lIns="73152" tIns="27432" rIns="54864" bIns="18288"/>
+          <a:lstStyle/>
+          <a:p>
+            <a:pPr algn="l"/>
+            <a:r>
+              <a:rPr sz="1200" b="1">
+                <a:solidFill>
+                  <a:srgbClr val="2B2A2F"/>
+                </a:solidFill>
+                <a:latin typeface="Aptos Display"/>
+              </a:rPr>
+              <a:t>US$17k</a:t>
+            </a:r>
+          </a:p>
+          <a:p>
+            <a:pPr algn="l"/>
+            <a:r>
+              <a:rPr sz="800" b="0">
+                <a:solidFill>
+                  <a:srgbClr val="2B2A2F"/>
+                </a:solidFill>
+                <a:latin typeface="Aptos"/>
+              </a:rPr>
+              <a:t>+ Customs / import expenses</a:t>
+            </a:r>
+          </a:p>
+        </p:txBody>
+      </p:sp>
+      <p:sp>
+        <p:nvSpPr>
+          <p:cNvPr id="18" name="Rectangle 17"/>
+          <p:cNvSpPr/>
+          <p:nvPr/>
+        </p:nvSpPr>
+        <p:spPr>
+          <a:xfrm>
+            <a:off x="6049074" y="2761488"/>
+            <a:ext cx="82296" cy="603504"/>
+          </a:xfrm>
+          <a:prstGeom prst="rect">
+            <a:avLst/>
+          </a:prstGeom>
+          <a:solidFill>
+            <a:srgbClr val="3685C0"/>
+          </a:solidFill>
+          <a:ln>
+            <a:noFill/>
+          </a:ln>
+          <a:effectLst/>
+        </p:spPr>
+        <p:style>
+          <a:lnRef idx="1">
+            <a:schemeClr val="accent1"/>
+          </a:lnRef>
+          <a:fillRef idx="3">
+            <a:schemeClr val="accent1"/>
+          </a:fillRef>
+          <a:effectRef idx="2">
+            <a:schemeClr val="accent1"/>
+          </a:effectRef>
+          <a:fontRef idx="minor">
+            <a:schemeClr val="lt1"/>
+          </a:fontRef>
+        </p:style>
+        <p:txBody>
+          <a:bodyPr rtlCol="0" anchor="ctr"/>
+          <a:lstStyle/>
+          <a:p>
+            <a:pPr algn="ctr"/>
+          </a:p>
+        </p:txBody>
+      </p:sp>
+      <p:sp>
+        <p:nvSpPr>
+          <p:cNvPr id="19" name="Rectangle 18"/>
+          <p:cNvSpPr/>
+          <p:nvPr/>
+        </p:nvSpPr>
+        <p:spPr>
+          <a:xfrm>
+            <a:off x="6131370" y="2761488"/>
+            <a:ext cx="1549589" cy="603504"/>
+          </a:xfrm>
+          <a:prstGeom prst="rect">
+            <a:avLst/>
+          </a:prstGeom>
+          <a:solidFill>
+            <a:srgbClr val="F8F8F8"/>
+          </a:solidFill>
+          <a:ln>
+            <a:noFill/>
+          </a:ln>
+          <a:effectLst/>
+        </p:spPr>
+        <p:style>
+          <a:lnRef idx="1">
+            <a:schemeClr val="accent1"/>
+          </a:lnRef>
+          <a:fillRef idx="3">
+            <a:schemeClr val="accent1"/>
+          </a:fillRef>
+          <a:effectRef idx="2">
+            <a:schemeClr val="accent1"/>
+          </a:effectRef>
+          <a:fontRef idx="minor">
+            <a:schemeClr val="lt1"/>
+          </a:fontRef>
+        </p:style>
+        <p:txBody>
+          <a:bodyPr rtlCol="0" anchor="t" wrap="square" lIns="73152" tIns="27432" rIns="54864" bIns="18288"/>
+          <a:lstStyle/>
+          <a:p>
+            <a:pPr algn="l"/>
+            <a:r>
+              <a:rPr sz="1200" b="1">
+                <a:solidFill>
+                  <a:srgbClr val="2B2A2F"/>
+                </a:solidFill>
+                <a:latin typeface="Aptos Display"/>
+              </a:rPr>
+              <a:t>US$716k</a:t>
+            </a:r>
+          </a:p>
+          <a:p>
+            <a:pPr algn="l"/>
+            <a:r>
+              <a:rPr sz="800" b="0">
+                <a:solidFill>
+                  <a:srgbClr val="2B2A2F"/>
+                </a:solidFill>
+                <a:latin typeface="Aptos"/>
+              </a:rPr>
+              <a:t>+ All import taxes (II, IPI, PIS/COFINS, ICMS)</a:t>
+            </a:r>
+          </a:p>
+        </p:txBody>
+      </p:sp>
+      <p:sp>
+        <p:nvSpPr>
+          <p:cNvPr id="20" name="Rectangle 19"/>
+          <p:cNvSpPr/>
+          <p:nvPr/>
+        </p:nvSpPr>
+        <p:spPr>
+          <a:xfrm>
+            <a:off x="6049074" y="3383280"/>
+            <a:ext cx="1631885" cy="365760"/>
+          </a:xfrm>
+          <a:prstGeom prst="rect">
+            <a:avLst/>
+          </a:prstGeom>
+          <a:noFill/>
           <a:ln w="9525">
             <a:solidFill>
               <a:srgbClr val="E1E0D9"/>
@@ -4059,25 +5249,34 @@
           </a:fontRef>
         </p:style>
         <p:txBody>
-          <a:bodyPr rtlCol="0" anchor="ctr" wrap="square" lIns="54864" tIns="27432" rIns="36576" bIns="27432"/>
+          <a:bodyPr rtlCol="0" anchor="ctr" wrap="square" lIns="73152" tIns="18288" rIns="54864" bIns="18288"/>
           <a:lstStyle/>
           <a:p>
             <a:pPr algn="l"/>
             <a:r>
-              <a:rPr sz="1100" b="1">
+              <a:rPr sz="1200" b="1">
                 <a:solidFill>
                   <a:srgbClr val="2B2A2F"/>
                 </a:solidFill>
+                <a:latin typeface="Aptos Display"/>
+              </a:rPr>
+              <a:t>US$1,713k  </a:t>
+            </a:r>
+            <a:r>
+              <a:rPr sz="800" b="0">
+                <a:solidFill>
+                  <a:srgbClr val="757588"/>
+                </a:solidFill>
                 <a:latin typeface="Aptos"/>
               </a:rPr>
-              <a:t>US domestic reference US$900k</a:t>
-            </a:r>
-          </a:p>
-        </p:txBody>
-      </p:sp>
-      <p:sp>
-        <p:nvSpPr>
-          <p:cNvPr id="11" name="Rectangle 10"/>
+              <a:t>= Landed in Brazil</a:t>
+            </a:r>
+          </a:p>
+        </p:txBody>
+      </p:sp>
+      <p:sp>
+        <p:nvSpPr>
+          <p:cNvPr id="21" name="Rectangle 20"/>
           <p:cNvSpPr/>
           <p:nvPr/>
         </p:nvSpPr>
@@ -4121,7 +5320,7 @@
       </p:sp>
       <p:sp>
         <p:nvSpPr>
-          <p:cNvPr id="12" name="Rectangle 11"/>
+          <p:cNvPr id="22" name="Rectangle 21"/>
           <p:cNvSpPr/>
           <p:nvPr/>
         </p:nvSpPr>
@@ -4186,7 +5385,7 @@
       </p:sp>
       <p:sp>
         <p:nvSpPr>
-          <p:cNvPr id="13" name="Rectangle 12"/>
+          <p:cNvPr id="23" name="Rectangle 22"/>
           <p:cNvSpPr/>
           <p:nvPr/>
         </p:nvSpPr>
@@ -4230,7 +5429,7 @@
       </p:sp>
       <p:sp>
         <p:nvSpPr>
-          <p:cNvPr id="14" name="Rectangle 13"/>
+          <p:cNvPr id="24" name="Rectangle 23"/>
           <p:cNvSpPr/>
           <p:nvPr/>
         </p:nvSpPr>
@@ -4295,7 +5494,7 @@
       </p:sp>
       <p:sp>
         <p:nvSpPr>
-          <p:cNvPr id="15" name="Rectangle 14"/>
+          <p:cNvPr id="25" name="Rectangle 24"/>
           <p:cNvSpPr/>
           <p:nvPr/>
         </p:nvSpPr>
@@ -4339,7 +5538,7 @@
       </p:sp>
       <p:sp>
         <p:nvSpPr>
-          <p:cNvPr id="16" name="Rectangle 15"/>
+          <p:cNvPr id="26" name="Rectangle 25"/>
           <p:cNvSpPr/>
           <p:nvPr/>
         </p:nvSpPr>
@@ -4385,7 +5584,7 @@
                 </a:solidFill>
                 <a:latin typeface="Aptos Display"/>
               </a:rPr>
-              <a:t>+34%</a:t>
+              <a:t>US$1,713k</a:t>
             </a:r>
           </a:p>
           <a:p>
@@ -4397,14 +5596,14 @@
                 </a:solidFill>
                 <a:latin typeface="Aptos"/>
               </a:rPr>
-              <a:t>Scenario 4 final price (US$1,210k) is still above the US$900k US reference</a:t>
-            </a:r>
-          </a:p>
-        </p:txBody>
-      </p:sp>
-      <p:sp>
-        <p:nvSpPr>
-          <p:cNvPr id="17" name="Rectangle 16"/>
+              <a:t>US$900k US price + US$80k freight/insurance + US$17k import expenses + US$716k import taxes</a:t>
+            </a:r>
+          </a:p>
+        </p:txBody>
+      </p:sp>
+      <p:sp>
+        <p:nvSpPr>
+          <p:cNvPr id="27" name="Rectangle 26"/>
           <p:cNvSpPr/>
           <p:nvPr/>
         </p:nvSpPr>
@@ -4457,7 +5656,7 @@
       </p:sp>
       <p:sp>
         <p:nvSpPr>
-          <p:cNvPr id="18" name="Rectangle 17"/>
+          <p:cNvPr id="28" name="Rectangle 27"/>
           <p:cNvSpPr/>
           <p:nvPr/>
         </p:nvSpPr>
@@ -4513,7 +5712,7 @@
                 </a:solidFill>
                 <a:latin typeface="Aptos"/>
               </a:rPr>
-              <a:t>Assumptions: TDM 45%; FX 5.10 BRL/USD; II 17.96% blended (only 6 of 47 imported items have a confirmed NCM, the rest at a worst-case 18%); PIS/COFINS 10.06%, ICMS 18%, IPI 9.69% passed through to MRS; Supermetal refurbishment included, no ISS; 27 items still without a quote are excluded. Source: workbook tab Simulation.</a:t>
+              <a:t>Assumptions (scenarios): TDM 45%; FX 5.10 BRL/USD; II 17.96% blended (only 6 of 47 imported items have a confirmed NCM, the rest at a worst-case 18%); PIS/COFINS 10.06%, ICMS 18%, IPI 9.69% passed through to MRS; Supermetal refurbishment included, no ISS; 27 items still without a quote are excluded. US landed reference: complete import-cost workbook ('Pathfinder Pronto' sheet), FX 5.15 BRL/USD, product US$900k + freight/insurance US$80.5k + import expenses US$16.8k + all import taxes US$715.7k = US$1,713.0k; not the same scope as the scenario estimates.</a:t>
             </a:r>
           </a:p>
         </p:txBody>
@@ -4626,7 +5825,7 @@
                 </a:solidFill>
                 <a:latin typeface="Aptos Display"/>
               </a:rPr>
-              <a:t>Sem importação, o Pathfinder segue caro: são os impostos locais</a:t>
+              <a:t>Mesmo sem II, os impostos locais encarecem o Pathfinder</a:t>
             </a:r>
           </a:p>
         </p:txBody>
@@ -4657,8 +5856,8 @@
         </p:nvSpPr>
         <p:spPr>
           <a:xfrm>
-            <a:off x="560070" y="1344259"/>
-            <a:ext cx="1463040" cy="420624"/>
+            <a:off x="654893" y="1679204"/>
+            <a:ext cx="1005840" cy="420624"/>
           </a:xfrm>
           <a:prstGeom prst="rect">
             <a:avLst/>
@@ -4689,7 +5888,7 @@
           <a:p>
             <a:pPr algn="ctr"/>
             <a:r>
-              <a:rPr sz="1600" b="1">
+              <a:rPr sz="1400" b="1">
                 <a:solidFill>
                   <a:srgbClr val="2B2A2F"/>
                 </a:solidFill>
@@ -4708,8 +5907,8 @@
         </p:nvSpPr>
         <p:spPr>
           <a:xfrm>
-            <a:off x="1897837" y="1569064"/>
-            <a:ext cx="1463040" cy="420624"/>
+            <a:off x="1725107" y="1868513"/>
+            <a:ext cx="1005840" cy="420624"/>
           </a:xfrm>
           <a:prstGeom prst="rect">
             <a:avLst/>
@@ -4740,7 +5939,7 @@
           <a:p>
             <a:pPr algn="ctr"/>
             <a:r>
-              <a:rPr sz="1600" b="1">
+              <a:rPr sz="1400" b="1">
                 <a:solidFill>
                   <a:srgbClr val="2B2A2F"/>
                 </a:solidFill>
@@ -4759,8 +5958,8 @@
         </p:nvSpPr>
         <p:spPr>
           <a:xfrm>
-            <a:off x="3235604" y="1428750"/>
-            <a:ext cx="1463040" cy="420624"/>
+            <a:off x="2795320" y="1750354"/>
+            <a:ext cx="1005840" cy="420624"/>
           </a:xfrm>
           <a:prstGeom prst="rect">
             <a:avLst/>
@@ -4791,7 +5990,7 @@
           <a:p>
             <a:pPr algn="ctr"/>
             <a:r>
-              <a:rPr sz="1600" b="1">
+              <a:rPr sz="1400" b="1">
                 <a:solidFill>
                   <a:srgbClr val="2B2A2F"/>
                 </a:solidFill>
@@ -4810,8 +6009,8 @@
         </p:nvSpPr>
         <p:spPr>
           <a:xfrm>
-            <a:off x="4573371" y="1639976"/>
-            <a:ext cx="1463040" cy="420624"/>
+            <a:off x="3865534" y="1928228"/>
+            <a:ext cx="1005840" cy="420624"/>
           </a:xfrm>
           <a:prstGeom prst="rect">
             <a:avLst/>
@@ -4842,7 +6041,7 @@
           <a:p>
             <a:pPr algn="ctr"/>
             <a:r>
-              <a:rPr sz="1600" b="1">
+              <a:rPr sz="1400" b="1">
                 <a:solidFill>
                   <a:srgbClr val="2B2A2F"/>
                 </a:solidFill>
@@ -4853,42 +6052,57 @@
           </a:p>
         </p:txBody>
       </p:sp>
-      <p:cxnSp>
-        <p:nvCxnSpPr>
-          <p:cNvPr id="9" name="Connector 8"/>
-          <p:cNvCxnSpPr/>
+      <p:sp>
+        <p:nvSpPr>
+          <p:cNvPr id="9" name="Rectangle 8"/>
+          <p:cNvSpPr/>
           <p:nvPr/>
-        </p:nvCxnSpPr>
+        </p:nvSpPr>
         <p:spPr>
           <a:xfrm>
-            <a:off x="622706" y="2564891"/>
-            <a:ext cx="5488229" cy="0"/>
+            <a:off x="4935748" y="1289149"/>
+            <a:ext cx="1005840" cy="420624"/>
           </a:xfrm>
-          <a:prstGeom prst="line">
+          <a:prstGeom prst="rect">
             <a:avLst/>
           </a:prstGeom>
-          <a:ln w="22225">
-            <a:solidFill>
-              <a:srgbClr val="2B2A2F"/>
-            </a:solidFill>
-            <a:prstDash val="dash"/>
+          <a:noFill/>
+          <a:ln>
+            <a:noFill/>
           </a:ln>
+          <a:effectLst/>
         </p:spPr>
         <p:style>
-          <a:lnRef idx="2">
+          <a:lnRef idx="1">
             <a:schemeClr val="accent1"/>
           </a:lnRef>
-          <a:fillRef idx="0">
+          <a:fillRef idx="3">
             <a:schemeClr val="accent1"/>
           </a:fillRef>
-          <a:effectRef idx="1">
+          <a:effectRef idx="2">
             <a:schemeClr val="accent1"/>
           </a:effectRef>
           <a:fontRef idx="minor">
-            <a:schemeClr val="tx1"/>
+            <a:schemeClr val="lt1"/>
           </a:fontRef>
         </p:style>
-      </p:cxnSp>
+        <p:txBody>
+          <a:bodyPr rtlCol="0" anchor="b" wrap="square" lIns="0" tIns="0" rIns="0" bIns="18288"/>
+          <a:lstStyle/>
+          <a:p>
+            <a:pPr algn="ctr"/>
+            <a:r>
+              <a:rPr sz="1400" b="1">
+                <a:solidFill>
+                  <a:srgbClr val="2B2A2F"/>
+                </a:solidFill>
+                <a:latin typeface="Aptos Display"/>
+              </a:rPr>
+              <a:t>US$1.713k</a:t>
+            </a:r>
+          </a:p>
+        </p:txBody>
+      </p:sp>
       <p:sp>
         <p:nvSpPr>
           <p:cNvPr id="10" name="Rectangle 9"/>
@@ -4897,8 +6111,149 @@
         </p:nvSpPr>
         <p:spPr>
           <a:xfrm>
-            <a:off x="6138367" y="2199132"/>
-            <a:ext cx="1313992" cy="731520"/>
+            <a:off x="5783898" y="2708318"/>
+            <a:ext cx="265176" cy="18288"/>
+          </a:xfrm>
+          <a:prstGeom prst="rect">
+            <a:avLst/>
+          </a:prstGeom>
+          <a:solidFill>
+            <a:srgbClr val="00847E"/>
+          </a:solidFill>
+          <a:ln>
+            <a:noFill/>
+          </a:ln>
+          <a:effectLst/>
+        </p:spPr>
+        <p:style>
+          <a:lnRef idx="1">
+            <a:schemeClr val="accent1"/>
+          </a:lnRef>
+          <a:fillRef idx="3">
+            <a:schemeClr val="accent1"/>
+          </a:fillRef>
+          <a:effectRef idx="2">
+            <a:schemeClr val="accent1"/>
+          </a:effectRef>
+          <a:fontRef idx="minor">
+            <a:schemeClr val="lt1"/>
+          </a:fontRef>
+        </p:style>
+        <p:txBody>
+          <a:bodyPr rtlCol="0" anchor="ctr"/>
+          <a:lstStyle/>
+          <a:p>
+            <a:pPr algn="ctr"/>
+          </a:p>
+        </p:txBody>
+      </p:sp>
+      <p:sp>
+        <p:nvSpPr>
+          <p:cNvPr id="11" name="Rectangle 10"/>
+          <p:cNvSpPr/>
+          <p:nvPr/>
+        </p:nvSpPr>
+        <p:spPr>
+          <a:xfrm>
+            <a:off x="6049074" y="1188720"/>
+            <a:ext cx="1631885" cy="310896"/>
+          </a:xfrm>
+          <a:prstGeom prst="rect">
+            <a:avLst/>
+          </a:prstGeom>
+          <a:solidFill>
+            <a:srgbClr val="003158"/>
+          </a:solidFill>
+          <a:ln>
+            <a:noFill/>
+          </a:ln>
+          <a:effectLst/>
+        </p:spPr>
+        <p:style>
+          <a:lnRef idx="1">
+            <a:schemeClr val="accent1"/>
+          </a:lnRef>
+          <a:fillRef idx="3">
+            <a:schemeClr val="accent1"/>
+          </a:fillRef>
+          <a:effectRef idx="2">
+            <a:schemeClr val="accent1"/>
+          </a:effectRef>
+          <a:fontRef idx="minor">
+            <a:schemeClr val="lt1"/>
+          </a:fontRef>
+        </p:style>
+        <p:txBody>
+          <a:bodyPr rtlCol="0" anchor="ctr" wrap="square" tIns="27432" rIns="73152" bIns="27432"/>
+          <a:lstStyle/>
+          <a:p>
+            <a:pPr algn="l"/>
+            <a:r>
+              <a:rPr sz="1100" b="1">
+                <a:solidFill>
+                  <a:srgbClr val="FFFFFF"/>
+                </a:solidFill>
+                <a:latin typeface="Aptos"/>
+              </a:rPr>
+              <a:t>Como os US$900k viram US$1.713k</a:t>
+            </a:r>
+          </a:p>
+        </p:txBody>
+      </p:sp>
+      <p:sp>
+        <p:nvSpPr>
+          <p:cNvPr id="12" name="Rectangle 11"/>
+          <p:cNvSpPr/>
+          <p:nvPr/>
+        </p:nvSpPr>
+        <p:spPr>
+          <a:xfrm>
+            <a:off x="6049074" y="1517904"/>
+            <a:ext cx="82296" cy="384048"/>
+          </a:xfrm>
+          <a:prstGeom prst="rect">
+            <a:avLst/>
+          </a:prstGeom>
+          <a:solidFill>
+            <a:srgbClr val="757588"/>
+          </a:solidFill>
+          <a:ln>
+            <a:noFill/>
+          </a:ln>
+          <a:effectLst/>
+        </p:spPr>
+        <p:style>
+          <a:lnRef idx="1">
+            <a:schemeClr val="accent1"/>
+          </a:lnRef>
+          <a:fillRef idx="3">
+            <a:schemeClr val="accent1"/>
+          </a:fillRef>
+          <a:effectRef idx="2">
+            <a:schemeClr val="accent1"/>
+          </a:effectRef>
+          <a:fontRef idx="minor">
+            <a:schemeClr val="lt1"/>
+          </a:fontRef>
+        </p:style>
+        <p:txBody>
+          <a:bodyPr rtlCol="0" anchor="ctr"/>
+          <a:lstStyle/>
+          <a:p>
+            <a:pPr algn="ctr"/>
+          </a:p>
+        </p:txBody>
+      </p:sp>
+      <p:sp>
+        <p:nvSpPr>
+          <p:cNvPr id="13" name="Rectangle 12"/>
+          <p:cNvSpPr/>
+          <p:nvPr/>
+        </p:nvSpPr>
+        <p:spPr>
+          <a:xfrm>
+            <a:off x="6131370" y="1517904"/>
+            <a:ext cx="1549589" cy="384048"/>
           </a:xfrm>
           <a:prstGeom prst="rect">
             <a:avLst/>
@@ -4906,6 +6261,396 @@
           <a:solidFill>
             <a:srgbClr val="F8F8F8"/>
           </a:solidFill>
+          <a:ln>
+            <a:noFill/>
+          </a:ln>
+          <a:effectLst/>
+        </p:spPr>
+        <p:style>
+          <a:lnRef idx="1">
+            <a:schemeClr val="accent1"/>
+          </a:lnRef>
+          <a:fillRef idx="3">
+            <a:schemeClr val="accent1"/>
+          </a:fillRef>
+          <a:effectRef idx="2">
+            <a:schemeClr val="accent1"/>
+          </a:effectRef>
+          <a:fontRef idx="minor">
+            <a:schemeClr val="lt1"/>
+          </a:fontRef>
+        </p:style>
+        <p:txBody>
+          <a:bodyPr rtlCol="0" anchor="t" wrap="square" lIns="73152" tIns="27432" rIns="54864" bIns="18288"/>
+          <a:lstStyle/>
+          <a:p>
+            <a:pPr algn="l"/>
+            <a:r>
+              <a:rPr sz="1200" b="1">
+                <a:solidFill>
+                  <a:srgbClr val="2B2A2F"/>
+                </a:solidFill>
+                <a:latin typeface="Aptos Display"/>
+              </a:rPr>
+              <a:t>US$900k</a:t>
+            </a:r>
+          </a:p>
+          <a:p>
+            <a:pPr algn="l"/>
+            <a:r>
+              <a:rPr sz="800" b="0">
+                <a:solidFill>
+                  <a:srgbClr val="2B2A2F"/>
+                </a:solidFill>
+                <a:latin typeface="Aptos"/>
+              </a:rPr>
+              <a:t>Preço EUA (produto, inalterado)</a:t>
+            </a:r>
+          </a:p>
+        </p:txBody>
+      </p:sp>
+      <p:sp>
+        <p:nvSpPr>
+          <p:cNvPr id="14" name="Rectangle 13"/>
+          <p:cNvSpPr/>
+          <p:nvPr/>
+        </p:nvSpPr>
+        <p:spPr>
+          <a:xfrm>
+            <a:off x="6049074" y="1920240"/>
+            <a:ext cx="82296" cy="384048"/>
+          </a:xfrm>
+          <a:prstGeom prst="rect">
+            <a:avLst/>
+          </a:prstGeom>
+          <a:solidFill>
+            <a:srgbClr val="00847E"/>
+          </a:solidFill>
+          <a:ln>
+            <a:noFill/>
+          </a:ln>
+          <a:effectLst/>
+        </p:spPr>
+        <p:style>
+          <a:lnRef idx="1">
+            <a:schemeClr val="accent1"/>
+          </a:lnRef>
+          <a:fillRef idx="3">
+            <a:schemeClr val="accent1"/>
+          </a:fillRef>
+          <a:effectRef idx="2">
+            <a:schemeClr val="accent1"/>
+          </a:effectRef>
+          <a:fontRef idx="minor">
+            <a:schemeClr val="lt1"/>
+          </a:fontRef>
+        </p:style>
+        <p:txBody>
+          <a:bodyPr rtlCol="0" anchor="ctr"/>
+          <a:lstStyle/>
+          <a:p>
+            <a:pPr algn="ctr"/>
+          </a:p>
+        </p:txBody>
+      </p:sp>
+      <p:sp>
+        <p:nvSpPr>
+          <p:cNvPr id="15" name="Rectangle 14"/>
+          <p:cNvSpPr/>
+          <p:nvPr/>
+        </p:nvSpPr>
+        <p:spPr>
+          <a:xfrm>
+            <a:off x="6131370" y="1920240"/>
+            <a:ext cx="1549589" cy="384048"/>
+          </a:xfrm>
+          <a:prstGeom prst="rect">
+            <a:avLst/>
+          </a:prstGeom>
+          <a:solidFill>
+            <a:srgbClr val="F8F8F8"/>
+          </a:solidFill>
+          <a:ln>
+            <a:noFill/>
+          </a:ln>
+          <a:effectLst/>
+        </p:spPr>
+        <p:style>
+          <a:lnRef idx="1">
+            <a:schemeClr val="accent1"/>
+          </a:lnRef>
+          <a:fillRef idx="3">
+            <a:schemeClr val="accent1"/>
+          </a:fillRef>
+          <a:effectRef idx="2">
+            <a:schemeClr val="accent1"/>
+          </a:effectRef>
+          <a:fontRef idx="minor">
+            <a:schemeClr val="lt1"/>
+          </a:fontRef>
+        </p:style>
+        <p:txBody>
+          <a:bodyPr rtlCol="0" anchor="t" wrap="square" lIns="73152" tIns="27432" rIns="54864" bIns="18288"/>
+          <a:lstStyle/>
+          <a:p>
+            <a:pPr algn="l"/>
+            <a:r>
+              <a:rPr sz="1200" b="1">
+                <a:solidFill>
+                  <a:srgbClr val="2B2A2F"/>
+                </a:solidFill>
+                <a:latin typeface="Aptos Display"/>
+              </a:rPr>
+              <a:t>US$80k</a:t>
+            </a:r>
+          </a:p>
+          <a:p>
+            <a:pPr algn="l"/>
+            <a:r>
+              <a:rPr sz="800" b="0">
+                <a:solidFill>
+                  <a:srgbClr val="2B2A2F"/>
+                </a:solidFill>
+                <a:latin typeface="Aptos"/>
+              </a:rPr>
+              <a:t>+ Frete + seguro</a:t>
+            </a:r>
+          </a:p>
+        </p:txBody>
+      </p:sp>
+      <p:sp>
+        <p:nvSpPr>
+          <p:cNvPr id="16" name="Rectangle 15"/>
+          <p:cNvSpPr/>
+          <p:nvPr/>
+        </p:nvSpPr>
+        <p:spPr>
+          <a:xfrm>
+            <a:off x="6049074" y="2322576"/>
+            <a:ext cx="82296" cy="420624"/>
+          </a:xfrm>
+          <a:prstGeom prst="rect">
+            <a:avLst/>
+          </a:prstGeom>
+          <a:solidFill>
+            <a:srgbClr val="FFAB18"/>
+          </a:solidFill>
+          <a:ln>
+            <a:noFill/>
+          </a:ln>
+          <a:effectLst/>
+        </p:spPr>
+        <p:style>
+          <a:lnRef idx="1">
+            <a:schemeClr val="accent1"/>
+          </a:lnRef>
+          <a:fillRef idx="3">
+            <a:schemeClr val="accent1"/>
+          </a:fillRef>
+          <a:effectRef idx="2">
+            <a:schemeClr val="accent1"/>
+          </a:effectRef>
+          <a:fontRef idx="minor">
+            <a:schemeClr val="lt1"/>
+          </a:fontRef>
+        </p:style>
+        <p:txBody>
+          <a:bodyPr rtlCol="0" anchor="ctr"/>
+          <a:lstStyle/>
+          <a:p>
+            <a:pPr algn="ctr"/>
+          </a:p>
+        </p:txBody>
+      </p:sp>
+      <p:sp>
+        <p:nvSpPr>
+          <p:cNvPr id="17" name="Rectangle 16"/>
+          <p:cNvSpPr/>
+          <p:nvPr/>
+        </p:nvSpPr>
+        <p:spPr>
+          <a:xfrm>
+            <a:off x="6131370" y="2322576"/>
+            <a:ext cx="1549589" cy="420624"/>
+          </a:xfrm>
+          <a:prstGeom prst="rect">
+            <a:avLst/>
+          </a:prstGeom>
+          <a:solidFill>
+            <a:srgbClr val="F8F8F8"/>
+          </a:solidFill>
+          <a:ln>
+            <a:noFill/>
+          </a:ln>
+          <a:effectLst/>
+        </p:spPr>
+        <p:style>
+          <a:lnRef idx="1">
+            <a:schemeClr val="accent1"/>
+          </a:lnRef>
+          <a:fillRef idx="3">
+            <a:schemeClr val="accent1"/>
+          </a:fillRef>
+          <a:effectRef idx="2">
+            <a:schemeClr val="accent1"/>
+          </a:effectRef>
+          <a:fontRef idx="minor">
+            <a:schemeClr val="lt1"/>
+          </a:fontRef>
+        </p:style>
+        <p:txBody>
+          <a:bodyPr rtlCol="0" anchor="t" wrap="square" lIns="73152" tIns="27432" rIns="54864" bIns="18288"/>
+          <a:lstStyle/>
+          <a:p>
+            <a:pPr algn="l"/>
+            <a:r>
+              <a:rPr sz="1200" b="1">
+                <a:solidFill>
+                  <a:srgbClr val="2B2A2F"/>
+                </a:solidFill>
+                <a:latin typeface="Aptos Display"/>
+              </a:rPr>
+              <a:t>US$17k</a:t>
+            </a:r>
+          </a:p>
+          <a:p>
+            <a:pPr algn="l"/>
+            <a:r>
+              <a:rPr sz="800" b="0">
+                <a:solidFill>
+                  <a:srgbClr val="2B2A2F"/>
+                </a:solidFill>
+                <a:latin typeface="Aptos"/>
+              </a:rPr>
+              <a:t>+ Despesas aduaneiras / importação</a:t>
+            </a:r>
+          </a:p>
+        </p:txBody>
+      </p:sp>
+      <p:sp>
+        <p:nvSpPr>
+          <p:cNvPr id="18" name="Rectangle 17"/>
+          <p:cNvSpPr/>
+          <p:nvPr/>
+        </p:nvSpPr>
+        <p:spPr>
+          <a:xfrm>
+            <a:off x="6049074" y="2761488"/>
+            <a:ext cx="82296" cy="603504"/>
+          </a:xfrm>
+          <a:prstGeom prst="rect">
+            <a:avLst/>
+          </a:prstGeom>
+          <a:solidFill>
+            <a:srgbClr val="3685C0"/>
+          </a:solidFill>
+          <a:ln>
+            <a:noFill/>
+          </a:ln>
+          <a:effectLst/>
+        </p:spPr>
+        <p:style>
+          <a:lnRef idx="1">
+            <a:schemeClr val="accent1"/>
+          </a:lnRef>
+          <a:fillRef idx="3">
+            <a:schemeClr val="accent1"/>
+          </a:fillRef>
+          <a:effectRef idx="2">
+            <a:schemeClr val="accent1"/>
+          </a:effectRef>
+          <a:fontRef idx="minor">
+            <a:schemeClr val="lt1"/>
+          </a:fontRef>
+        </p:style>
+        <p:txBody>
+          <a:bodyPr rtlCol="0" anchor="ctr"/>
+          <a:lstStyle/>
+          <a:p>
+            <a:pPr algn="ctr"/>
+          </a:p>
+        </p:txBody>
+      </p:sp>
+      <p:sp>
+        <p:nvSpPr>
+          <p:cNvPr id="19" name="Rectangle 18"/>
+          <p:cNvSpPr/>
+          <p:nvPr/>
+        </p:nvSpPr>
+        <p:spPr>
+          <a:xfrm>
+            <a:off x="6131370" y="2761488"/>
+            <a:ext cx="1549589" cy="603504"/>
+          </a:xfrm>
+          <a:prstGeom prst="rect">
+            <a:avLst/>
+          </a:prstGeom>
+          <a:solidFill>
+            <a:srgbClr val="F8F8F8"/>
+          </a:solidFill>
+          <a:ln>
+            <a:noFill/>
+          </a:ln>
+          <a:effectLst/>
+        </p:spPr>
+        <p:style>
+          <a:lnRef idx="1">
+            <a:schemeClr val="accent1"/>
+          </a:lnRef>
+          <a:fillRef idx="3">
+            <a:schemeClr val="accent1"/>
+          </a:fillRef>
+          <a:effectRef idx="2">
+            <a:schemeClr val="accent1"/>
+          </a:effectRef>
+          <a:fontRef idx="minor">
+            <a:schemeClr val="lt1"/>
+          </a:fontRef>
+        </p:style>
+        <p:txBody>
+          <a:bodyPr rtlCol="0" anchor="t" wrap="square" lIns="73152" tIns="27432" rIns="54864" bIns="18288"/>
+          <a:lstStyle/>
+          <a:p>
+            <a:pPr algn="l"/>
+            <a:r>
+              <a:rPr sz="1200" b="1">
+                <a:solidFill>
+                  <a:srgbClr val="2B2A2F"/>
+                </a:solidFill>
+                <a:latin typeface="Aptos Display"/>
+              </a:rPr>
+              <a:t>US$716k</a:t>
+            </a:r>
+          </a:p>
+          <a:p>
+            <a:pPr algn="l"/>
+            <a:r>
+              <a:rPr sz="800" b="0">
+                <a:solidFill>
+                  <a:srgbClr val="2B2A2F"/>
+                </a:solidFill>
+                <a:latin typeface="Aptos"/>
+              </a:rPr>
+              <a:t>+ Todos os impostos de importação (II, IPI, PIS/COFINS, ICMS)</a:t>
+            </a:r>
+          </a:p>
+        </p:txBody>
+      </p:sp>
+      <p:sp>
+        <p:nvSpPr>
+          <p:cNvPr id="20" name="Rectangle 19"/>
+          <p:cNvSpPr/>
+          <p:nvPr/>
+        </p:nvSpPr>
+        <p:spPr>
+          <a:xfrm>
+            <a:off x="6049074" y="3383280"/>
+            <a:ext cx="1631885" cy="365760"/>
+          </a:xfrm>
+          <a:prstGeom prst="rect">
+            <a:avLst/>
+          </a:prstGeom>
+          <a:noFill/>
           <a:ln w="9525">
             <a:solidFill>
               <a:srgbClr val="E1E0D9"/>
@@ -4928,25 +6673,34 @@
           </a:fontRef>
         </p:style>
         <p:txBody>
-          <a:bodyPr rtlCol="0" anchor="ctr" wrap="square" lIns="54864" tIns="27432" rIns="36576" bIns="27432"/>
+          <a:bodyPr rtlCol="0" anchor="ctr" wrap="square" lIns="73152" tIns="18288" rIns="54864" bIns="18288"/>
           <a:lstStyle/>
           <a:p>
             <a:pPr algn="l"/>
             <a:r>
-              <a:rPr sz="1100" b="1">
+              <a:rPr sz="1200" b="1">
                 <a:solidFill>
                   <a:srgbClr val="2B2A2F"/>
                 </a:solidFill>
+                <a:latin typeface="Aptos Display"/>
+              </a:rPr>
+              <a:t>US$1.713k  </a:t>
+            </a:r>
+            <a:r>
+              <a:rPr sz="800" b="0">
+                <a:solidFill>
+                  <a:srgbClr val="757588"/>
+                </a:solidFill>
                 <a:latin typeface="Aptos"/>
               </a:rPr>
-              <a:t>Referência doméstica EUA US$900k</a:t>
-            </a:r>
-          </a:p>
-        </p:txBody>
-      </p:sp>
-      <p:sp>
-        <p:nvSpPr>
-          <p:cNvPr id="11" name="Rectangle 10"/>
+              <a:t>= Posto no Brasil</a:t>
+            </a:r>
+          </a:p>
+        </p:txBody>
+      </p:sp>
+      <p:sp>
+        <p:nvSpPr>
+          <p:cNvPr id="21" name="Rectangle 20"/>
           <p:cNvSpPr/>
           <p:nvPr/>
         </p:nvSpPr>
@@ -4990,7 +6744,7 @@
       </p:sp>
       <p:sp>
         <p:nvSpPr>
-          <p:cNvPr id="12" name="Rectangle 11"/>
+          <p:cNvPr id="22" name="Rectangle 21"/>
           <p:cNvSpPr/>
           <p:nvPr/>
         </p:nvSpPr>
@@ -5055,7 +6809,7 @@
       </p:sp>
       <p:sp>
         <p:nvSpPr>
-          <p:cNvPr id="13" name="Rectangle 12"/>
+          <p:cNvPr id="23" name="Rectangle 22"/>
           <p:cNvSpPr/>
           <p:nvPr/>
         </p:nvSpPr>
@@ -5099,7 +6853,7 @@
       </p:sp>
       <p:sp>
         <p:nvSpPr>
-          <p:cNvPr id="14" name="Rectangle 13"/>
+          <p:cNvPr id="24" name="Rectangle 23"/>
           <p:cNvSpPr/>
           <p:nvPr/>
         </p:nvSpPr>
@@ -5164,7 +6918,7 @@
       </p:sp>
       <p:sp>
         <p:nvSpPr>
-          <p:cNvPr id="15" name="Rectangle 14"/>
+          <p:cNvPr id="25" name="Rectangle 24"/>
           <p:cNvSpPr/>
           <p:nvPr/>
         </p:nvSpPr>
@@ -5208,7 +6962,7 @@
       </p:sp>
       <p:sp>
         <p:nvSpPr>
-          <p:cNvPr id="16" name="Rectangle 15"/>
+          <p:cNvPr id="26" name="Rectangle 25"/>
           <p:cNvSpPr/>
           <p:nvPr/>
         </p:nvSpPr>
@@ -5254,7 +7008,7 @@
                 </a:solidFill>
                 <a:latin typeface="Aptos Display"/>
               </a:rPr>
-              <a:t>+34%</a:t>
+              <a:t>US$1.713k</a:t>
             </a:r>
           </a:p>
           <a:p>
@@ -5266,14 +7020,14 @@
                 </a:solidFill>
                 <a:latin typeface="Aptos"/>
               </a:rPr>
-              <a:t>O preço final do cenário 4 (US$1.210k) ainda fica acima da referência EUA de US$900k</a:t>
-            </a:r>
-          </a:p>
-        </p:txBody>
-      </p:sp>
-      <p:sp>
-        <p:nvSpPr>
-          <p:cNvPr id="17" name="Rectangle 16"/>
+              <a:t>Preço EUA US$900k + US$80k frete/seguro + US$17k despesas + US$716k impostos de importação</a:t>
+            </a:r>
+          </a:p>
+        </p:txBody>
+      </p:sp>
+      <p:sp>
+        <p:nvSpPr>
+          <p:cNvPr id="27" name="Rectangle 26"/>
           <p:cNvSpPr/>
           <p:nvPr/>
         </p:nvSpPr>
@@ -5326,7 +7080,7 @@
       </p:sp>
       <p:sp>
         <p:nvSpPr>
-          <p:cNvPr id="18" name="Rectangle 17"/>
+          <p:cNvPr id="28" name="Rectangle 27"/>
           <p:cNvSpPr/>
           <p:nvPr/>
         </p:nvSpPr>
@@ -5382,7 +7136,7 @@
                 </a:solidFill>
                 <a:latin typeface="Aptos"/>
               </a:rPr>
-              <a:t>Premissas: TDM 45%; câmbio 5,10 BRL/USD; II 17,96% médio (só 6 de 47 itens importados têm NCM confirmada, o restante a 18% pior caso); PIS/COFINS 10,06%, ICMS 18%, IPI 9,69% repassados à MRS; reforma da Supermetal incluída, sem ISS; 27 itens ainda sem cotação excluídos. Fonte: aba Simulação da planilha.</a:t>
+              <a:t>Premissas (cenários): TDM 45%; câmbio 5,10 BRL/USD; II 17,96% médio (só 6 de 47 itens importados têm NCM confirmada, o restante a 18% pior caso); PIS/COFINS 10,06%, ICMS 18%, IPI 9,69% repassados à MRS; reforma da Supermetal incluída, sem ISS; 27 itens ainda sem cotação excluídos. Referência EUA posta: planilha completa de importação (aba 'Pathfinder Pronto'), câmbio 5,15 BRL/USD, produto US$900k + frete/seguro US$80,5k + despesas de importação US$16,8k + todos os impostos de importação US$715,7k = US$1.713,0k; escopo diferente das simulações.</a:t>
             </a:r>
           </a:p>
         </p:txBody>

</xml_diff>